<commit_message>
Point repo references to new home: pumaduma/RehabLens
</commit_message>
<xml_diff>
--- a/pitch/RehabLens_Pitch_Deck.pptx
+++ b/pitch/RehabLens_Pitch_Deck.pptx
@@ -4866,7 +4866,7 @@
                 </a:solidFill>
                 <a:latin typeface="Calibri"/>
               </a:rPr>
-              <a:t>Team: [name] · [name] · [name]     Coach: [name]     github.com/alicialiu540-oss/Conrad-project</a:t>
+              <a:t>Team: [name] · [name] · [name]     Coach: [name]     github.com/pumaduma/RehabLens</a:t>
             </a:r>
           </a:p>
         </p:txBody>
@@ -8193,7 +8193,7 @@
                 </a:solidFill>
                 <a:latin typeface="Calibri"/>
               </a:rPr>
-              <a:t>github.com/alicialiu540-oss/Conrad-project  →  demo/</a:t>
+              <a:t>pumaduma.github.io/RehabLens  (live demo)</a:t>
             </a:r>
           </a:p>
           <a:p>

</xml_diff>